<commit_message>
atualizado os slides do dia 3
</commit_message>
<xml_diff>
--- a/slides/dia3/Slides Capacitação Python Dia 3.pptx
+++ b/slides/dia3/Slides Capacitação Python Dia 3.pptx
@@ -18321,7 +18321,7 @@
                 <a:cs typeface="JetBrains Mono"/>
                 <a:sym typeface="JetBrains Mono"/>
               </a:rPr>
-              <a:t>“, assim, o bloco de código é executado indefinidamente enquanto a condição é verdadeira (true)</a:t>
+              <a:t>“, assim, o bloco de código é executado indefinidamente enquanto a condição for verdadeira (true)</a:t>
             </a:r>
           </a:p>
           <a:p>
@@ -23779,7 +23779,7 @@
                 <a:cs typeface="JetBrains Mono"/>
                 <a:sym typeface="JetBrains Mono"/>
               </a:rPr>
-              <a:t>A mãe de João pediu para ele ir as compras, porém ele acha que escrever a lista no papel é algo muito ultrapassado. Pensando nisso, ele te contratou pra que desenvolva um programa onde ele possa criar uma lista de compras, adicionar um item para comprar, removê-lo caso tenha sido comprado, e procurar por itens, além de exibir todos os que estão atualmente na lista!</a:t>
+              <a:t>A mãe de João pediu para ele ir as compras, porém ele acha que escrever a lista no papel é algo muito ultrapassado. Pensando nisso, ele te contratou pra que desenvolva um programa onde ele possa criar uma lista de compras, adicionar um item para comprar, removê-lo caso tenha sido comprado além de exibir todos os que estão atualmente na lista!</a:t>
             </a:r>
           </a:p>
           <a:p>

</xml_diff>